<commit_message>
Cinematic landing page, live transcript fixes and README update
Adds the /welcome scroll film with graded footage, soundtrack and beat-synced visuals, fixes live transcription and distress display, and refreshes the README.
</commit_message>
<xml_diff>
--- a/ANVESH_Presentation.pptx
+++ b/ANVESH_Presentation.pptx
@@ -111,27 +111,27 @@
   <p:extLst>
     <p:ext uri="{521415D9-36F7-43E2-AB2F-B90AF26B5E84}">
       <p14:sectionLst xmlns:p14="http://schemas.microsoft.com/office/powerpoint/2010/main">
-        <p14:section name="Problem" id="{604affb4-2f59-1881-6cb8-bbfe8f0f7fb9}">
+        <p14:section name="Problem" id="{83944472-1fb3-6c9e-548d-a85c68f38ad8}">
           <p14:sldIdLst>
             <p14:sldId id="256"/>
           </p14:sldIdLst>
         </p14:section>
-        <p14:section name="Approach" id="{5240bfe2-7a55-f644-7e2e-a6b6758f4c19}">
+        <p14:section name="Approach" id="{a4d135e1-9a65-5889-5d2d-5828c0d94487}">
           <p14:sldIdLst>
             <p14:sldId id="257"/>
           </p14:sldIdLst>
         </p14:section>
-        <p14:section name="Feasibility" id="{52a4ff44-66e7-0800-cd7f-227cab6ba880}">
+        <p14:section name="Feasibility" id="{ff521adb-0eca-1cdc-c782-a4be2c249815}">
           <p14:sldIdLst>
             <p14:sldId id="258"/>
           </p14:sldIdLst>
         </p14:section>
-        <p14:section name="Impact" id="{44c0933e-16b6-f46d-0f01-fc0136266c2b}">
+        <p14:section name="Impact" id="{2fe04eed-2023-1846-843a-ae2882701793}">
           <p14:sldIdLst>
             <p14:sldId id="259"/>
           </p14:sldIdLst>
         </p14:section>
-        <p14:section name="Comparison" id="{5faa10e4-fadc-1fb8-cba7-92b1b78a430e}">
+        <p14:section name="Comparison" id="{5ee2422f-d3cf-295b-37f4-4b4ef0f429e2}">
           <p14:sldIdLst>
             <p14:sldId id="260"/>
           </p14:sldIdLst>
@@ -1940,7 +1940,7 @@
         <p:spPr>
           <a:xfrm>
             <a:off x="320040" y="6583680"/>
-            <a:ext cx="4572000" cy="182880"/>
+            <a:ext cx="731520" cy="182880"/>
           </a:xfrm>
           <a:prstGeom prst="rect">
             <a:avLst/>
@@ -1956,15 +1956,15 @@
               <a:buNone/>
             </a:pPr>
             <a:r>
-              <a:rPr lang="en-US" sz="750" dirty="0">
-                <a:solidFill>
-                  <a:srgbClr val="98A2B3"/>
-                </a:solidFill>
-                <a:latin typeface="Inter" pitchFamily="34" charset="0"/>
-                <a:ea typeface="Inter" pitchFamily="34" charset="-122"/>
-                <a:cs typeface="Inter" pitchFamily="34" charset="-120"/>
-              </a:rPr>
-              <a:t>ANVESH  ·  every call solves more than one case</a:t>
+              <a:rPr lang="en-US" sz="750" b="1" dirty="0">
+                <a:solidFill>
+                  <a:srgbClr val="C2570C"/>
+                </a:solidFill>
+                <a:latin typeface="Inter" pitchFamily="34" charset="0"/>
+                <a:ea typeface="Inter" pitchFamily="34" charset="-122"/>
+                <a:cs typeface="Inter" pitchFamily="34" charset="-120"/>
+              </a:rPr>
+              <a:t>Team Nexora</a:t>
             </a:r>
             <a:endParaRPr lang="en-US" sz="750" dirty="0"/>
           </a:p>
@@ -1974,8 +1974,47 @@
         <p:nvSpPr>
           <p:cNvPr id="5" name="Text 2"/>
           <p:cNvSpPr/>
+          <p:nvPr/>
+        </p:nvSpPr>
+        <p:spPr>
+          <a:xfrm>
+            <a:off x="960120" y="6583680"/>
+            <a:ext cx="4572000" cy="182880"/>
+          </a:xfrm>
+          <a:prstGeom prst="rect">
+            <a:avLst/>
+          </a:prstGeom>
+          <a:noFill/>
+          <a:ln/>
+        </p:spPr>
+        <p:txBody>
+          <a:bodyPr wrap="square" lIns="0" tIns="0" rIns="0" bIns="0" rtlCol="0" anchor="ctr"/>
+          <a:lstStyle/>
+          <a:p>
+            <a:pPr indent="0" marL="0">
+              <a:buNone/>
+            </a:pPr>
+            <a:r>
+              <a:rPr lang="en-US" sz="750" dirty="0">
+                <a:solidFill>
+                  <a:srgbClr val="98A2B3"/>
+                </a:solidFill>
+                <a:latin typeface="Inter" pitchFamily="34" charset="0"/>
+                <a:ea typeface="Inter" pitchFamily="34" charset="-122"/>
+                <a:cs typeface="Inter" pitchFamily="34" charset="-120"/>
+              </a:rPr>
+              <a:t>·  ANVESH  ·  every call solves more than one case</a:t>
+            </a:r>
+            <a:endParaRPr lang="en-US" sz="750" dirty="0"/>
+          </a:p>
+        </p:txBody>
+      </p:sp>
+      <p:sp>
+        <p:nvSpPr>
+          <p:cNvPr id="6" name="Text 3"/>
+          <p:cNvSpPr/>
           <p:nvPr>
-            <p:ph idx="103" type="title" hasCustomPrompt="1"/>
+            <p:ph idx="104" type="title" hasCustomPrompt="1"/>
           </p:nvPr>
         </p:nvSpPr>
         <p:spPr>
@@ -2407,10 +2446,10 @@
       </p:grpSpPr>
       <p:sp>
         <p:nvSpPr>
-          <p:cNvPr id="2" name="Text 2"/>
+          <p:cNvPr id="2" name="Text 3"/>
           <p:cNvSpPr/>
           <p:nvPr>
-            <p:ph idx="103" type="title" hasCustomPrompt="1"/>
+            <p:ph idx="104" type="title" hasCustomPrompt="1"/>
           </p:nvPr>
         </p:nvSpPr>
         <p:spPr>
@@ -5496,10 +5535,10 @@
       </p:grpSpPr>
       <p:sp>
         <p:nvSpPr>
-          <p:cNvPr id="2" name="Text 2"/>
+          <p:cNvPr id="2" name="Text 3"/>
           <p:cNvSpPr/>
           <p:nvPr>
-            <p:ph idx="103" type="title" hasCustomPrompt="1"/>
+            <p:ph idx="104" type="title" hasCustomPrompt="1"/>
           </p:nvPr>
         </p:nvSpPr>
         <p:spPr>
@@ -5687,8 +5726,8 @@
         </p:nvSpPr>
         <p:spPr>
           <a:xfrm>
-            <a:off x="1810512" y="1097280"/>
-            <a:ext cx="155448" cy="914"/>
+            <a:off x="1819656" y="1792224"/>
+            <a:ext cx="137160" cy="914"/>
           </a:xfrm>
           <a:prstGeom prst="line">
             <a:avLst/>
@@ -5855,8 +5894,8 @@
         </p:nvSpPr>
         <p:spPr>
           <a:xfrm>
-            <a:off x="3502152" y="1097280"/>
-            <a:ext cx="155448" cy="914"/>
+            <a:off x="3511296" y="1792224"/>
+            <a:ext cx="137160" cy="914"/>
           </a:xfrm>
           <a:prstGeom prst="line">
             <a:avLst/>
@@ -6023,8 +6062,8 @@
         </p:nvSpPr>
         <p:spPr>
           <a:xfrm>
-            <a:off x="5193792" y="1097280"/>
-            <a:ext cx="155448" cy="914"/>
+            <a:off x="5202936" y="1792224"/>
+            <a:ext cx="137160" cy="914"/>
           </a:xfrm>
           <a:prstGeom prst="line">
             <a:avLst/>
@@ -6191,8 +6230,8 @@
         </p:nvSpPr>
         <p:spPr>
           <a:xfrm>
-            <a:off x="6885432" y="1097280"/>
-            <a:ext cx="155448" cy="914"/>
+            <a:off x="6894576" y="1792224"/>
+            <a:ext cx="137160" cy="914"/>
           </a:xfrm>
           <a:prstGeom prst="line">
             <a:avLst/>
@@ -6359,8 +6398,8 @@
         </p:nvSpPr>
         <p:spPr>
           <a:xfrm>
-            <a:off x="8577072" y="1097280"/>
-            <a:ext cx="155448" cy="914"/>
+            <a:off x="8586216" y="1792224"/>
+            <a:ext cx="137160" cy="914"/>
           </a:xfrm>
           <a:prstGeom prst="line">
             <a:avLst/>
@@ -6527,8 +6566,8 @@
         </p:nvSpPr>
         <p:spPr>
           <a:xfrm>
-            <a:off x="10268712" y="1097280"/>
-            <a:ext cx="155448" cy="914"/>
+            <a:off x="10277856" y="1792224"/>
+            <a:ext cx="137160" cy="914"/>
           </a:xfrm>
           <a:prstGeom prst="line">
             <a:avLst/>
@@ -11482,10 +11521,10 @@
       </p:grpSpPr>
       <p:sp>
         <p:nvSpPr>
-          <p:cNvPr id="2" name="Text 2"/>
+          <p:cNvPr id="2" name="Text 3"/>
           <p:cNvSpPr/>
           <p:nvPr>
-            <p:ph idx="103" type="title" hasCustomPrompt="1"/>
+            <p:ph idx="104" type="title" hasCustomPrompt="1"/>
           </p:nvPr>
         </p:nvSpPr>
         <p:spPr>
@@ -12043,11 +12082,15 @@
           <a:bodyPr wrap="square" lIns="0" tIns="0" rIns="0" bIns="0" rtlCol="0" anchor="t"/>
           <a:lstStyle/>
           <a:p>
-            <a:pPr marL="101600" indent="-101600">
+            <a:pPr marL="155448" indent="-155448">
               <a:spcAft>
                 <a:spcPts val="300"/>
               </a:spcAft>
-              <a:buSzPct val="100000"/>
+              <a:buClr>
+                <a:srgbClr val="F97A0F"/>
+              </a:buClr>
+              <a:buSzPct val="110000"/>
+              <a:buFont typeface="Arial" panose="020B0604020202020204" pitchFamily="34" charset="0"/>
               <a:buChar char="•"/>
             </a:pPr>
             <a:r>
@@ -12064,11 +12107,15 @@
             <a:endParaRPr lang="en-US" sz="790" dirty="0"/>
           </a:p>
           <a:p>
-            <a:pPr marL="101600" indent="-101600">
+            <a:pPr marL="155448" indent="-155448">
               <a:spcAft>
                 <a:spcPts val="300"/>
               </a:spcAft>
-              <a:buSzPct val="100000"/>
+              <a:buClr>
+                <a:srgbClr val="F97A0F"/>
+              </a:buClr>
+              <a:buSzPct val="110000"/>
+              <a:buFont typeface="Arial" panose="020B0604020202020204" pitchFamily="34" charset="0"/>
               <a:buChar char="•"/>
             </a:pPr>
             <a:r>
@@ -12085,11 +12132,15 @@
             <a:endParaRPr lang="en-US" sz="790" dirty="0"/>
           </a:p>
           <a:p>
-            <a:pPr marL="101600" indent="-101600">
+            <a:pPr marL="155448" indent="-155448">
               <a:spcAft>
                 <a:spcPts val="300"/>
               </a:spcAft>
-              <a:buSzPct val="100000"/>
+              <a:buClr>
+                <a:srgbClr val="F97A0F"/>
+              </a:buClr>
+              <a:buSzPct val="110000"/>
+              <a:buFont typeface="Arial" panose="020B0604020202020204" pitchFamily="34" charset="0"/>
               <a:buChar char="•"/>
             </a:pPr>
             <a:r>
@@ -12106,11 +12157,15 @@
             <a:endParaRPr lang="en-US" sz="790" dirty="0"/>
           </a:p>
           <a:p>
-            <a:pPr marL="101600" indent="-101600">
+            <a:pPr marL="155448" indent="-155448">
               <a:spcAft>
                 <a:spcPts val="300"/>
               </a:spcAft>
-              <a:buSzPct val="100000"/>
+              <a:buClr>
+                <a:srgbClr val="F97A0F"/>
+              </a:buClr>
+              <a:buSzPct val="110000"/>
+              <a:buFont typeface="Arial" panose="020B0604020202020204" pitchFamily="34" charset="0"/>
               <a:buChar char="•"/>
             </a:pPr>
             <a:r>
@@ -12215,11 +12270,15 @@
           <a:bodyPr wrap="square" lIns="0" tIns="0" rIns="0" bIns="0" rtlCol="0" anchor="t"/>
           <a:lstStyle/>
           <a:p>
-            <a:pPr marL="101600" indent="-101600">
+            <a:pPr marL="155448" indent="-155448">
               <a:spcAft>
                 <a:spcPts val="300"/>
               </a:spcAft>
-              <a:buSzPct val="100000"/>
+              <a:buClr>
+                <a:srgbClr val="F97A0F"/>
+              </a:buClr>
+              <a:buSzPct val="110000"/>
+              <a:buFont typeface="Arial" panose="020B0604020202020204" pitchFamily="34" charset="0"/>
               <a:buChar char="•"/>
             </a:pPr>
             <a:r>
@@ -12236,11 +12295,15 @@
             <a:endParaRPr lang="en-US" sz="790" dirty="0"/>
           </a:p>
           <a:p>
-            <a:pPr marL="101600" indent="-101600">
+            <a:pPr marL="155448" indent="-155448">
               <a:spcAft>
                 <a:spcPts val="300"/>
               </a:spcAft>
-              <a:buSzPct val="100000"/>
+              <a:buClr>
+                <a:srgbClr val="F97A0F"/>
+              </a:buClr>
+              <a:buSzPct val="110000"/>
+              <a:buFont typeface="Arial" panose="020B0604020202020204" pitchFamily="34" charset="0"/>
               <a:buChar char="•"/>
             </a:pPr>
             <a:r>
@@ -12257,11 +12320,15 @@
             <a:endParaRPr lang="en-US" sz="790" dirty="0"/>
           </a:p>
           <a:p>
-            <a:pPr marL="101600" indent="-101600">
+            <a:pPr marL="155448" indent="-155448">
               <a:spcAft>
                 <a:spcPts val="300"/>
               </a:spcAft>
-              <a:buSzPct val="100000"/>
+              <a:buClr>
+                <a:srgbClr val="F97A0F"/>
+              </a:buClr>
+              <a:buSzPct val="110000"/>
+              <a:buFont typeface="Arial" panose="020B0604020202020204" pitchFamily="34" charset="0"/>
               <a:buChar char="•"/>
             </a:pPr>
             <a:r>
@@ -12278,11 +12345,15 @@
             <a:endParaRPr lang="en-US" sz="790" dirty="0"/>
           </a:p>
           <a:p>
-            <a:pPr marL="101600" indent="-101600">
+            <a:pPr marL="155448" indent="-155448">
               <a:spcAft>
                 <a:spcPts val="300"/>
               </a:spcAft>
-              <a:buSzPct val="100000"/>
+              <a:buClr>
+                <a:srgbClr val="F97A0F"/>
+              </a:buClr>
+              <a:buSzPct val="110000"/>
+              <a:buFont typeface="Arial" panose="020B0604020202020204" pitchFamily="34" charset="0"/>
               <a:buChar char="•"/>
             </a:pPr>
             <a:r>
@@ -12387,11 +12458,15 @@
           <a:bodyPr wrap="square" lIns="0" tIns="0" rIns="0" bIns="0" rtlCol="0" anchor="t"/>
           <a:lstStyle/>
           <a:p>
-            <a:pPr marL="101600" indent="-101600">
+            <a:pPr marL="155448" indent="-155448">
               <a:spcAft>
                 <a:spcPts val="300"/>
               </a:spcAft>
-              <a:buSzPct val="100000"/>
+              <a:buClr>
+                <a:srgbClr val="F97A0F"/>
+              </a:buClr>
+              <a:buSzPct val="110000"/>
+              <a:buFont typeface="Arial" panose="020B0604020202020204" pitchFamily="34" charset="0"/>
               <a:buChar char="•"/>
             </a:pPr>
             <a:r>
@@ -12408,11 +12483,15 @@
             <a:endParaRPr lang="en-US" sz="790" dirty="0"/>
           </a:p>
           <a:p>
-            <a:pPr marL="101600" indent="-101600">
+            <a:pPr marL="155448" indent="-155448">
               <a:spcAft>
                 <a:spcPts val="300"/>
               </a:spcAft>
-              <a:buSzPct val="100000"/>
+              <a:buClr>
+                <a:srgbClr val="F97A0F"/>
+              </a:buClr>
+              <a:buSzPct val="110000"/>
+              <a:buFont typeface="Arial" panose="020B0604020202020204" pitchFamily="34" charset="0"/>
               <a:buChar char="•"/>
             </a:pPr>
             <a:r>
@@ -12429,11 +12508,15 @@
             <a:endParaRPr lang="en-US" sz="790" dirty="0"/>
           </a:p>
           <a:p>
-            <a:pPr marL="101600" indent="-101600">
+            <a:pPr marL="155448" indent="-155448">
               <a:spcAft>
                 <a:spcPts val="300"/>
               </a:spcAft>
-              <a:buSzPct val="100000"/>
+              <a:buClr>
+                <a:srgbClr val="F97A0F"/>
+              </a:buClr>
+              <a:buSzPct val="110000"/>
+              <a:buFont typeface="Arial" panose="020B0604020202020204" pitchFamily="34" charset="0"/>
               <a:buChar char="•"/>
             </a:pPr>
             <a:r>
@@ -12450,11 +12533,15 @@
             <a:endParaRPr lang="en-US" sz="790" dirty="0"/>
           </a:p>
           <a:p>
-            <a:pPr marL="101600" indent="-101600">
+            <a:pPr marL="155448" indent="-155448">
               <a:spcAft>
                 <a:spcPts val="300"/>
               </a:spcAft>
-              <a:buSzPct val="100000"/>
+              <a:buClr>
+                <a:srgbClr val="F97A0F"/>
+              </a:buClr>
+              <a:buSzPct val="110000"/>
+              <a:buFont typeface="Arial" panose="020B0604020202020204" pitchFamily="34" charset="0"/>
               <a:buChar char="•"/>
             </a:pPr>
             <a:r>
@@ -14600,7 +14687,7 @@
         <p:spPr>
           <a:xfrm>
             <a:off x="6309360" y="4069080"/>
-            <a:ext cx="1737360" cy="987552"/>
+            <a:ext cx="1700784" cy="987552"/>
           </a:xfrm>
           <a:prstGeom prst="roundRect">
             <a:avLst>
@@ -14627,7 +14714,7 @@
         <p:spPr>
           <a:xfrm>
             <a:off x="6400800" y="4142232"/>
-            <a:ext cx="1600200" cy="292608"/>
+            <a:ext cx="1554480" cy="292608"/>
           </a:xfrm>
           <a:prstGeom prst="rect">
             <a:avLst/>
@@ -14665,7 +14752,7 @@
         </p:nvSpPr>
         <p:spPr>
           <a:xfrm>
-            <a:off x="7452360" y="4828032"/>
+            <a:off x="7406640" y="4828032"/>
             <a:ext cx="530352" cy="164592"/>
           </a:xfrm>
           <a:prstGeom prst="roundRect">
@@ -14692,7 +14779,7 @@
         </p:nvSpPr>
         <p:spPr>
           <a:xfrm>
-            <a:off x="7452360" y="4828032"/>
+            <a:off x="7406640" y="4828032"/>
             <a:ext cx="530352" cy="164592"/>
           </a:xfrm>
           <a:prstGeom prst="rect">
@@ -14732,7 +14819,7 @@
         <p:spPr>
           <a:xfrm>
             <a:off x="6400800" y="4471416"/>
-            <a:ext cx="1600200" cy="365760"/>
+            <a:ext cx="1554480" cy="365760"/>
           </a:xfrm>
           <a:prstGeom prst="rect">
             <a:avLst/>
@@ -14770,8 +14857,8 @@
         </p:nvSpPr>
         <p:spPr>
           <a:xfrm>
-            <a:off x="8065008" y="4562856"/>
-            <a:ext cx="128016" cy="914"/>
+            <a:off x="8037576" y="4562856"/>
+            <a:ext cx="182880" cy="914"/>
           </a:xfrm>
           <a:prstGeom prst="line">
             <a:avLst/>
@@ -14794,8 +14881,8 @@
         </p:nvSpPr>
         <p:spPr>
           <a:xfrm>
-            <a:off x="8211312" y="4069080"/>
-            <a:ext cx="1737360" cy="987552"/>
+            <a:off x="8247888" y="4069080"/>
+            <a:ext cx="1700784" cy="987552"/>
           </a:xfrm>
           <a:prstGeom prst="roundRect">
             <a:avLst>
@@ -14821,8 +14908,8 @@
         </p:nvSpPr>
         <p:spPr>
           <a:xfrm>
-            <a:off x="8302752" y="4142232"/>
-            <a:ext cx="1600200" cy="292608"/>
+            <a:off x="8339328" y="4142232"/>
+            <a:ext cx="1554480" cy="292608"/>
           </a:xfrm>
           <a:prstGeom prst="rect">
             <a:avLst/>
@@ -14860,7 +14947,7 @@
         </p:nvSpPr>
         <p:spPr>
           <a:xfrm>
-            <a:off x="9354312" y="4828032"/>
+            <a:off x="9345168" y="4828032"/>
             <a:ext cx="530352" cy="164592"/>
           </a:xfrm>
           <a:prstGeom prst="roundRect">
@@ -14887,7 +14974,7 @@
         </p:nvSpPr>
         <p:spPr>
           <a:xfrm>
-            <a:off x="9354312" y="4828032"/>
+            <a:off x="9345168" y="4828032"/>
             <a:ext cx="530352" cy="164592"/>
           </a:xfrm>
           <a:prstGeom prst="rect">
@@ -14926,8 +15013,8 @@
         </p:nvSpPr>
         <p:spPr>
           <a:xfrm>
-            <a:off x="8302752" y="4471416"/>
-            <a:ext cx="1600200" cy="365760"/>
+            <a:off x="8339328" y="4471416"/>
+            <a:ext cx="1554480" cy="365760"/>
           </a:xfrm>
           <a:prstGeom prst="rect">
             <a:avLst/>
@@ -14965,8 +15052,8 @@
         </p:nvSpPr>
         <p:spPr>
           <a:xfrm>
-            <a:off x="9966960" y="4562856"/>
-            <a:ext cx="128016" cy="914"/>
+            <a:off x="9976104" y="4562856"/>
+            <a:ext cx="182880" cy="914"/>
           </a:xfrm>
           <a:prstGeom prst="line">
             <a:avLst/>
@@ -14989,8 +15076,8 @@
         </p:nvSpPr>
         <p:spPr>
           <a:xfrm>
-            <a:off x="10113264" y="4069080"/>
-            <a:ext cx="1737360" cy="987552"/>
+            <a:off x="10186416" y="4069080"/>
+            <a:ext cx="1700784" cy="987552"/>
           </a:xfrm>
           <a:prstGeom prst="roundRect">
             <a:avLst>
@@ -15016,8 +15103,8 @@
         </p:nvSpPr>
         <p:spPr>
           <a:xfrm>
-            <a:off x="10204704" y="4142232"/>
-            <a:ext cx="1600200" cy="292608"/>
+            <a:off x="10277856" y="4142232"/>
+            <a:ext cx="1554480" cy="292608"/>
           </a:xfrm>
           <a:prstGeom prst="rect">
             <a:avLst/>
@@ -15055,7 +15142,7 @@
         </p:nvSpPr>
         <p:spPr>
           <a:xfrm>
-            <a:off x="11256264" y="4828032"/>
+            <a:off x="11283696" y="4828032"/>
             <a:ext cx="530352" cy="164592"/>
           </a:xfrm>
           <a:prstGeom prst="roundRect">
@@ -15082,7 +15169,7 @@
         </p:nvSpPr>
         <p:spPr>
           <a:xfrm>
-            <a:off x="11256264" y="4828032"/>
+            <a:off x="11283696" y="4828032"/>
             <a:ext cx="530352" cy="164592"/>
           </a:xfrm>
           <a:prstGeom prst="rect">
@@ -15121,8 +15208,8 @@
         </p:nvSpPr>
         <p:spPr>
           <a:xfrm>
-            <a:off x="10204704" y="4471416"/>
-            <a:ext cx="1600200" cy="365760"/>
+            <a:off x="10277856" y="4471416"/>
+            <a:ext cx="1554480" cy="365760"/>
           </a:xfrm>
           <a:prstGeom prst="rect">
             <a:avLst/>
@@ -15220,11 +15307,15 @@
             <a:endParaRPr lang="en-US" sz="950" dirty="0"/>
           </a:p>
           <a:p>
-            <a:pPr marL="101600" indent="-101600">
+            <a:pPr marL="155448" indent="-155448">
               <a:spcAft>
                 <a:spcPts val="200"/>
               </a:spcAft>
-              <a:buSzPct val="100000"/>
+              <a:buClr>
+                <a:srgbClr val="F97A0F"/>
+              </a:buClr>
+              <a:buSzPct val="110000"/>
+              <a:buFont typeface="Arial" panose="020B0604020202020204" pitchFamily="34" charset="0"/>
               <a:buChar char="•"/>
             </a:pPr>
             <a:r>
@@ -15241,11 +15332,15 @@
             <a:endParaRPr lang="en-US" sz="950" dirty="0"/>
           </a:p>
           <a:p>
-            <a:pPr marL="101600" indent="-101600">
+            <a:pPr marL="155448" indent="-155448">
               <a:spcAft>
                 <a:spcPts val="200"/>
               </a:spcAft>
-              <a:buSzPct val="100000"/>
+              <a:buClr>
+                <a:srgbClr val="F97A0F"/>
+              </a:buClr>
+              <a:buSzPct val="110000"/>
+              <a:buFont typeface="Arial" panose="020B0604020202020204" pitchFamily="34" charset="0"/>
               <a:buChar char="•"/>
             </a:pPr>
             <a:r>
@@ -15262,11 +15357,15 @@
             <a:endParaRPr lang="en-US" sz="950" dirty="0"/>
           </a:p>
           <a:p>
-            <a:pPr marL="101600" indent="-101600">
+            <a:pPr marL="155448" indent="-155448">
               <a:spcAft>
                 <a:spcPts val="200"/>
               </a:spcAft>
-              <a:buSzPct val="100000"/>
+              <a:buClr>
+                <a:srgbClr val="F97A0F"/>
+              </a:buClr>
+              <a:buSzPct val="110000"/>
+              <a:buFont typeface="Arial" panose="020B0604020202020204" pitchFamily="34" charset="0"/>
               <a:buChar char="•"/>
             </a:pPr>
             <a:r>
@@ -15352,11 +15451,15 @@
             <a:endParaRPr lang="en-US" sz="950" dirty="0"/>
           </a:p>
           <a:p>
-            <a:pPr marL="101600" indent="-101600">
+            <a:pPr marL="155448" indent="-155448">
               <a:spcAft>
                 <a:spcPts val="100"/>
               </a:spcAft>
-              <a:buSzPct val="100000"/>
+              <a:buClr>
+                <a:srgbClr val="F97A0F"/>
+              </a:buClr>
+              <a:buSzPct val="110000"/>
+              <a:buFont typeface="Arial" panose="020B0604020202020204" pitchFamily="34" charset="0"/>
               <a:buChar char="•"/>
             </a:pPr>
             <a:r>
@@ -15373,11 +15476,15 @@
             <a:endParaRPr lang="en-US" sz="950" dirty="0"/>
           </a:p>
           <a:p>
-            <a:pPr marL="101600" indent="-101600">
+            <a:pPr marL="155448" indent="-155448">
               <a:spcAft>
                 <a:spcPts val="100"/>
               </a:spcAft>
-              <a:buSzPct val="100000"/>
+              <a:buClr>
+                <a:srgbClr val="F97A0F"/>
+              </a:buClr>
+              <a:buSzPct val="110000"/>
+              <a:buFont typeface="Arial" panose="020B0604020202020204" pitchFamily="34" charset="0"/>
               <a:buChar char="•"/>
             </a:pPr>
             <a:r>
@@ -15394,11 +15501,15 @@
             <a:endParaRPr lang="en-US" sz="950" dirty="0"/>
           </a:p>
           <a:p>
-            <a:pPr marL="101600" indent="-101600">
+            <a:pPr marL="155448" indent="-155448">
               <a:spcAft>
                 <a:spcPts val="100"/>
               </a:spcAft>
-              <a:buSzPct val="100000"/>
+              <a:buClr>
+                <a:srgbClr val="F97A0F"/>
+              </a:buClr>
+              <a:buSzPct val="110000"/>
+              <a:buFont typeface="Arial" panose="020B0604020202020204" pitchFamily="34" charset="0"/>
               <a:buChar char="•"/>
             </a:pPr>
             <a:r>
@@ -15415,11 +15526,15 @@
             <a:endParaRPr lang="en-US" sz="950" dirty="0"/>
           </a:p>
           <a:p>
-            <a:pPr marL="101600" indent="-101600">
+            <a:pPr marL="155448" indent="-155448">
               <a:spcAft>
                 <a:spcPts val="100"/>
               </a:spcAft>
-              <a:buSzPct val="100000"/>
+              <a:buClr>
+                <a:srgbClr val="F97A0F"/>
+              </a:buClr>
+              <a:buSzPct val="110000"/>
+              <a:buFont typeface="Arial" panose="020B0604020202020204" pitchFamily="34" charset="0"/>
               <a:buChar char="•"/>
             </a:pPr>
             <a:r>
@@ -15548,10 +15663,10 @@
       </p:grpSpPr>
       <p:sp>
         <p:nvSpPr>
-          <p:cNvPr id="2" name="Text 2"/>
+          <p:cNvPr id="2" name="Text 3"/>
           <p:cNvSpPr/>
           <p:nvPr>
-            <p:ph idx="103" type="title" hasCustomPrompt="1"/>
+            <p:ph idx="104" type="title" hasCustomPrompt="1"/>
           </p:nvPr>
         </p:nvSpPr>
         <p:spPr>
@@ -15674,11 +15789,15 @@
           <a:bodyPr wrap="square" lIns="0" tIns="0" rIns="0" bIns="0" rtlCol="0" anchor="t"/>
           <a:lstStyle/>
           <a:p>
-            <a:pPr marL="127000" indent="-127000">
+            <a:pPr marL="155448" indent="-155448">
               <a:spcAft>
                 <a:spcPts val="300"/>
               </a:spcAft>
-              <a:buSzPct val="100000"/>
+              <a:buClr>
+                <a:srgbClr val="F97A0F"/>
+              </a:buClr>
+              <a:buSzPct val="110000"/>
+              <a:buFont typeface="Arial" panose="020B0604020202020204" pitchFamily="34" charset="0"/>
               <a:buChar char="•"/>
             </a:pPr>
             <a:r>
@@ -15695,11 +15814,15 @@
             <a:endParaRPr lang="en-US" sz="900" dirty="0"/>
           </a:p>
           <a:p>
-            <a:pPr marL="127000" indent="-127000">
+            <a:pPr marL="155448" indent="-155448">
               <a:spcAft>
                 <a:spcPts val="300"/>
               </a:spcAft>
-              <a:buSzPct val="100000"/>
+              <a:buClr>
+                <a:srgbClr val="F97A0F"/>
+              </a:buClr>
+              <a:buSzPct val="110000"/>
+              <a:buFont typeface="Arial" panose="020B0604020202020204" pitchFamily="34" charset="0"/>
               <a:buChar char="•"/>
             </a:pPr>
             <a:r>
@@ -15716,11 +15839,15 @@
             <a:endParaRPr lang="en-US" sz="900" dirty="0"/>
           </a:p>
           <a:p>
-            <a:pPr marL="127000" indent="-127000">
+            <a:pPr marL="155448" indent="-155448">
               <a:spcAft>
                 <a:spcPts val="300"/>
               </a:spcAft>
-              <a:buSzPct val="100000"/>
+              <a:buClr>
+                <a:srgbClr val="F97A0F"/>
+              </a:buClr>
+              <a:buSzPct val="110000"/>
+              <a:buFont typeface="Arial" panose="020B0604020202020204" pitchFamily="34" charset="0"/>
               <a:buChar char="•"/>
             </a:pPr>
             <a:r>
@@ -15825,11 +15952,15 @@
           <a:bodyPr wrap="square" lIns="0" tIns="0" rIns="0" bIns="0" rtlCol="0" anchor="t"/>
           <a:lstStyle/>
           <a:p>
-            <a:pPr marL="127000" indent="-127000">
+            <a:pPr marL="155448" indent="-155448">
               <a:spcAft>
                 <a:spcPts val="300"/>
               </a:spcAft>
-              <a:buSzPct val="100000"/>
+              <a:buClr>
+                <a:srgbClr val="F97A0F"/>
+              </a:buClr>
+              <a:buSzPct val="110000"/>
+              <a:buFont typeface="Arial" panose="020B0604020202020204" pitchFamily="34" charset="0"/>
               <a:buChar char="•"/>
             </a:pPr>
             <a:r>
@@ -15846,11 +15977,15 @@
             <a:endParaRPr lang="en-US" sz="900" dirty="0"/>
           </a:p>
           <a:p>
-            <a:pPr marL="127000" indent="-127000">
+            <a:pPr marL="155448" indent="-155448">
               <a:spcAft>
                 <a:spcPts val="300"/>
               </a:spcAft>
-              <a:buSzPct val="100000"/>
+              <a:buClr>
+                <a:srgbClr val="F97A0F"/>
+              </a:buClr>
+              <a:buSzPct val="110000"/>
+              <a:buFont typeface="Arial" panose="020B0604020202020204" pitchFamily="34" charset="0"/>
               <a:buChar char="•"/>
             </a:pPr>
             <a:r>
@@ -15867,11 +16002,15 @@
             <a:endParaRPr lang="en-US" sz="900" dirty="0"/>
           </a:p>
           <a:p>
-            <a:pPr marL="127000" indent="-127000">
+            <a:pPr marL="155448" indent="-155448">
               <a:spcAft>
                 <a:spcPts val="300"/>
               </a:spcAft>
-              <a:buSzPct val="100000"/>
+              <a:buClr>
+                <a:srgbClr val="F97A0F"/>
+              </a:buClr>
+              <a:buSzPct val="110000"/>
+              <a:buFont typeface="Arial" panose="020B0604020202020204" pitchFamily="34" charset="0"/>
               <a:buChar char="•"/>
             </a:pPr>
             <a:r>
@@ -15976,11 +16115,15 @@
           <a:bodyPr wrap="square" lIns="0" tIns="0" rIns="0" bIns="0" rtlCol="0" anchor="t"/>
           <a:lstStyle/>
           <a:p>
-            <a:pPr marL="127000" indent="-127000">
+            <a:pPr marL="155448" indent="-155448">
               <a:spcAft>
                 <a:spcPts val="300"/>
               </a:spcAft>
-              <a:buSzPct val="100000"/>
+              <a:buClr>
+                <a:srgbClr val="F97A0F"/>
+              </a:buClr>
+              <a:buSzPct val="110000"/>
+              <a:buFont typeface="Arial" panose="020B0604020202020204" pitchFamily="34" charset="0"/>
               <a:buChar char="•"/>
             </a:pPr>
             <a:r>
@@ -15997,11 +16140,15 @@
             <a:endParaRPr lang="en-US" sz="900" dirty="0"/>
           </a:p>
           <a:p>
-            <a:pPr marL="127000" indent="-127000">
+            <a:pPr marL="155448" indent="-155448">
               <a:spcAft>
                 <a:spcPts val="300"/>
               </a:spcAft>
-              <a:buSzPct val="100000"/>
+              <a:buClr>
+                <a:srgbClr val="F97A0F"/>
+              </a:buClr>
+              <a:buSzPct val="110000"/>
+              <a:buFont typeface="Arial" panose="020B0604020202020204" pitchFamily="34" charset="0"/>
               <a:buChar char="•"/>
             </a:pPr>
             <a:r>
@@ -16106,11 +16253,15 @@
           <a:bodyPr wrap="square" lIns="0" tIns="0" rIns="0" bIns="0" rtlCol="0" anchor="t"/>
           <a:lstStyle/>
           <a:p>
-            <a:pPr marL="127000" indent="-127000">
+            <a:pPr marL="155448" indent="-155448">
               <a:spcAft>
                 <a:spcPts val="300"/>
               </a:spcAft>
-              <a:buSzPct val="100000"/>
+              <a:buClr>
+                <a:srgbClr val="F97A0F"/>
+              </a:buClr>
+              <a:buSzPct val="110000"/>
+              <a:buFont typeface="Arial" panose="020B0604020202020204" pitchFamily="34" charset="0"/>
               <a:buChar char="•"/>
             </a:pPr>
             <a:r>
@@ -16127,11 +16278,15 @@
             <a:endParaRPr lang="en-US" sz="900" dirty="0"/>
           </a:p>
           <a:p>
-            <a:pPr marL="127000" indent="-127000">
+            <a:pPr marL="155448" indent="-155448">
               <a:spcAft>
                 <a:spcPts val="300"/>
               </a:spcAft>
-              <a:buSzPct val="100000"/>
+              <a:buClr>
+                <a:srgbClr val="F97A0F"/>
+              </a:buClr>
+              <a:buSzPct val="110000"/>
+              <a:buFont typeface="Arial" panose="020B0604020202020204" pitchFamily="34" charset="0"/>
               <a:buChar char="•"/>
             </a:pPr>
             <a:r>
@@ -17420,7 +17575,7 @@
         <p:spPr>
           <a:xfrm>
             <a:off x="8613648" y="4242816"/>
-            <a:ext cx="1481328" cy="347472"/>
+            <a:ext cx="1426464" cy="347472"/>
           </a:xfrm>
           <a:prstGeom prst="roundRect">
             <a:avLst>
@@ -17447,7 +17602,7 @@
         <p:spPr>
           <a:xfrm>
             <a:off x="8668512" y="4242816"/>
-            <a:ext cx="1389888" cy="347472"/>
+            <a:ext cx="1335024" cy="347472"/>
           </a:xfrm>
           <a:prstGeom prst="rect">
             <a:avLst/>
@@ -17485,14 +17640,14 @@
         </p:nvSpPr>
         <p:spPr>
           <a:xfrm>
-            <a:off x="10113264" y="4416552"/>
-            <a:ext cx="128016" cy="914"/>
+            <a:off x="10067544" y="4416552"/>
+            <a:ext cx="164592" cy="914"/>
           </a:xfrm>
           <a:prstGeom prst="line">
             <a:avLst/>
           </a:prstGeom>
           <a:noFill/>
-          <a:ln w="15875">
+          <a:ln w="19050">
             <a:solidFill>
               <a:srgbClr val="F97A0F"/>
             </a:solidFill>
@@ -17576,7 +17731,7 @@
         <p:spPr>
           <a:xfrm>
             <a:off x="8613648" y="4636008"/>
-            <a:ext cx="1481328" cy="347472"/>
+            <a:ext cx="1426464" cy="347472"/>
           </a:xfrm>
           <a:prstGeom prst="roundRect">
             <a:avLst>
@@ -17603,7 +17758,7 @@
         <p:spPr>
           <a:xfrm>
             <a:off x="8668512" y="4636008"/>
-            <a:ext cx="1389888" cy="347472"/>
+            <a:ext cx="1335024" cy="347472"/>
           </a:xfrm>
           <a:prstGeom prst="rect">
             <a:avLst/>
@@ -17641,14 +17796,14 @@
         </p:nvSpPr>
         <p:spPr>
           <a:xfrm>
-            <a:off x="10113264" y="4809744"/>
-            <a:ext cx="128016" cy="914"/>
+            <a:off x="10067544" y="4809744"/>
+            <a:ext cx="164592" cy="914"/>
           </a:xfrm>
           <a:prstGeom prst="line">
             <a:avLst/>
           </a:prstGeom>
           <a:noFill/>
-          <a:ln w="15875">
+          <a:ln w="19050">
             <a:solidFill>
               <a:srgbClr val="F97A0F"/>
             </a:solidFill>
@@ -17732,7 +17887,7 @@
         <p:spPr>
           <a:xfrm>
             <a:off x="8613648" y="5029200"/>
-            <a:ext cx="1481328" cy="347472"/>
+            <a:ext cx="1426464" cy="347472"/>
           </a:xfrm>
           <a:prstGeom prst="roundRect">
             <a:avLst>
@@ -17759,7 +17914,7 @@
         <p:spPr>
           <a:xfrm>
             <a:off x="8668512" y="5029200"/>
-            <a:ext cx="1389888" cy="347472"/>
+            <a:ext cx="1335024" cy="347472"/>
           </a:xfrm>
           <a:prstGeom prst="rect">
             <a:avLst/>
@@ -17797,14 +17952,14 @@
         </p:nvSpPr>
         <p:spPr>
           <a:xfrm>
-            <a:off x="10113264" y="5202936"/>
-            <a:ext cx="128016" cy="914"/>
+            <a:off x="10067544" y="5202936"/>
+            <a:ext cx="164592" cy="914"/>
           </a:xfrm>
           <a:prstGeom prst="line">
             <a:avLst/>
           </a:prstGeom>
           <a:noFill/>
-          <a:ln w="15875">
+          <a:ln w="19050">
             <a:solidFill>
               <a:srgbClr val="F97A0F"/>
             </a:solidFill>
@@ -17888,7 +18043,7 @@
         <p:spPr>
           <a:xfrm>
             <a:off x="8613648" y="5422392"/>
-            <a:ext cx="1481328" cy="347472"/>
+            <a:ext cx="1426464" cy="347472"/>
           </a:xfrm>
           <a:prstGeom prst="roundRect">
             <a:avLst>
@@ -17915,7 +18070,7 @@
         <p:spPr>
           <a:xfrm>
             <a:off x="8668512" y="5422392"/>
-            <a:ext cx="1389888" cy="347472"/>
+            <a:ext cx="1335024" cy="347472"/>
           </a:xfrm>
           <a:prstGeom prst="rect">
             <a:avLst/>
@@ -17953,14 +18108,14 @@
         </p:nvSpPr>
         <p:spPr>
           <a:xfrm>
-            <a:off x="10113264" y="5596128"/>
-            <a:ext cx="128016" cy="914"/>
+            <a:off x="10067544" y="5596128"/>
+            <a:ext cx="164592" cy="914"/>
           </a:xfrm>
           <a:prstGeom prst="line">
             <a:avLst/>
           </a:prstGeom>
           <a:noFill/>
-          <a:ln w="15875">
+          <a:ln w="19050">
             <a:solidFill>
               <a:srgbClr val="F97A0F"/>
             </a:solidFill>
@@ -18044,7 +18199,7 @@
         <p:spPr>
           <a:xfrm>
             <a:off x="8613648" y="5815584"/>
-            <a:ext cx="1481328" cy="347472"/>
+            <a:ext cx="1426464" cy="347472"/>
           </a:xfrm>
           <a:prstGeom prst="roundRect">
             <a:avLst>
@@ -18071,7 +18226,7 @@
         <p:spPr>
           <a:xfrm>
             <a:off x="8668512" y="5815584"/>
-            <a:ext cx="1389888" cy="347472"/>
+            <a:ext cx="1335024" cy="347472"/>
           </a:xfrm>
           <a:prstGeom prst="rect">
             <a:avLst/>
@@ -18109,14 +18264,14 @@
         </p:nvSpPr>
         <p:spPr>
           <a:xfrm>
-            <a:off x="10113264" y="5989320"/>
-            <a:ext cx="128016" cy="914"/>
+            <a:off x="10067544" y="5989320"/>
+            <a:ext cx="164592" cy="914"/>
           </a:xfrm>
           <a:prstGeom prst="line">
             <a:avLst/>
           </a:prstGeom>
           <a:noFill/>
-          <a:ln w="15875">
+          <a:ln w="19050">
             <a:solidFill>
               <a:srgbClr val="F97A0F"/>
             </a:solidFill>
@@ -18302,10 +18457,10 @@
       </p:grpSpPr>
       <p:sp>
         <p:nvSpPr>
-          <p:cNvPr id="2" name="Text 2"/>
+          <p:cNvPr id="2" name="Text 3"/>
           <p:cNvSpPr/>
           <p:nvPr>
-            <p:ph idx="103" type="title" hasCustomPrompt="1"/>
+            <p:ph idx="104" type="title" hasCustomPrompt="1"/>
           </p:nvPr>
         </p:nvSpPr>
         <p:spPr>

</xml_diff>